<commit_message>
docs(presentation): update Tencent paper citation and fix caption typo in PI-GUARD-Present-109.pptx
</commit_message>
<xml_diff>
--- a/Final-Report/reports/PI-GUARD-Present-109.pptx
+++ b/Final-Report/reports/PI-GUARD-Present-109.pptx
@@ -11800,7 +11800,7 @@
                 <a:cs typeface="Noto Sans Bold"/>
                 <a:sym typeface="Noto Sans Bold"/>
               </a:rPr>
-              <a:t> attack surface &amp; independent inspection boundary for AI agents (Tencent Zhuque Lab, 2026, Figure 1 [4])</a:t>
+              <a:t> attack surface &amp; independent inspection boundary for AI agents (Xiao et al. / Tencent Zhuque Lab, 2026, Figure 1 [4])</a:t>
             </a:r>
           </a:p>
         </p:txBody>
@@ -24124,7 +24124,7 @@
                 <a:cs typeface="Noto Sans Bold"/>
                 <a:sym typeface="Noto Sans Bold"/>
               </a:rPr>
-              <a:t>&amp; Saltzer-Saltzer-Schroeder Security Principles) [8]</a:t>
+              <a:t>&amp; Saltzer-Schroeder Security Principles) [8]</a:t>
             </a:r>
           </a:p>
         </p:txBody>
@@ -32025,7 +32025,7 @@
                 <a:cs typeface="Proxima Nova Bold"/>
                 <a:sym typeface="Proxima Nova Bold"/>
               </a:rPr>
-              <a:t>[4] Tencent Zhuque Lab (2026) </a:t>
+              <a:t>[4] Xiao et al. / Tencent Zhuque Lab (2026) </a:t>
             </a:r>
             <a:r>
               <a:rPr lang="en-US" sz="1599" i="true">
@@ -32037,7 +32037,7 @@
                 <a:cs typeface="Proxima Nova Italics"/>
                 <a:sym typeface="Proxima Nova Italics"/>
               </a:rPr>
-              <a:t> — AI-Infra-Guard: Multi-Layer Attack Surface and Defense Framework for AI Agents.</a:t>
+              <a:t> — Securing the AI Agent: A Unified Framework for Multi-Layer Agent Red Teaming.</a:t>
             </a:r>
           </a:p>
           <a:p>
@@ -32056,7 +32056,7 @@
                 <a:cs typeface="Proxima Nova"/>
                 <a:sym typeface="Proxima Nova"/>
               </a:rPr>
-              <a:t>Tencent Security Technical Report, 2026.</a:t>
+              <a:t>Tencent Security Technical Report / arXiv:2606.31227, 2026.</a:t>
             </a:r>
           </a:p>
           <a:p>

</xml_diff>

<commit_message>
chore(convergence): harmonize academic defense terminology, sync meeting 4 records, and update docs portal
</commit_message>
<xml_diff>
--- a/Final-Report/reports/PI-GUARD-Present-109.pptx
+++ b/Final-Report/reports/PI-GUARD-Present-109.pptx
@@ -152,6 +152,1201 @@
     </a:lvl9pPr>
   </p:defaultTextStyle>
 </p:presentation>
+</file>
+
+<file path=ppt/notesMasters/notesMaster1.xml><?xml version="1.0" encoding="utf-8"?>
+<p:notesMaster xmlns:a="http://schemas.openxmlformats.org/drawingml/2006/main" xmlns:p="http://schemas.openxmlformats.org/presentationml/2006/main" xmlns:r="http://schemas.openxmlformats.org/officeDocument/2006/relationships">
+  <p:cSld>
+    <p:bg>
+      <p:bgRef idx="1001">
+        <a:schemeClr val="bg1"/>
+      </p:bgRef>
+    </p:bg>
+    <p:spTree>
+      <p:nvGrpSpPr>
+        <p:cNvPr id="1" name=""/>
+        <p:cNvGrpSpPr/>
+        <p:nvPr/>
+      </p:nvGrpSpPr>
+      <p:grpSpPr>
+        <a:xfrm>
+          <a:off x="0" y="0"/>
+          <a:ext cx="0" cy="0"/>
+          <a:chOff x="0" y="0"/>
+          <a:chExt cx="0" cy="0"/>
+        </a:xfrm>
+      </p:grpSpPr>
+      <p:sp>
+        <p:nvSpPr>
+          <p:cNvPr id="2" name="Header Placeholder 1"/>
+          <p:cNvSpPr>
+            <a:spLocks noGrp="1"/>
+          </p:cNvSpPr>
+          <p:nvPr>
+            <p:ph type="hdr" sz="quarter"/>
+          </p:nvPr>
+        </p:nvSpPr>
+        <p:spPr>
+          <a:xfrm>
+            <a:off x="0" y="0"/>
+            <a:ext cx="2971800" cy="457200"/>
+          </a:xfrm>
+          <a:prstGeom prst="rect">
+            <a:avLst/>
+          </a:prstGeom>
+        </p:spPr>
+        <p:txBody>
+          <a:bodyPr vert="horz" lIns="91440" tIns="45720" rIns="91440" bIns="45720" rtlCol="0"/>
+          <a:lstStyle>
+            <a:lvl1pPr algn="l">
+              <a:defRPr sz="1200"/>
+            </a:lvl1pPr>
+          </a:lstStyle>
+          <a:p>
+            <a:endParaRPr lang="en-US"/>
+          </a:p>
+        </p:txBody>
+      </p:sp>
+      <p:sp>
+        <p:nvSpPr>
+          <p:cNvPr id="3" name="Date Placeholder 2"/>
+          <p:cNvSpPr>
+            <a:spLocks noGrp="1"/>
+          </p:cNvSpPr>
+          <p:nvPr>
+            <p:ph type="dt" idx="1"/>
+          </p:nvPr>
+        </p:nvSpPr>
+        <p:spPr>
+          <a:xfrm>
+            <a:off x="3884613" y="0"/>
+            <a:ext cx="2971800" cy="457200"/>
+          </a:xfrm>
+          <a:prstGeom prst="rect">
+            <a:avLst/>
+          </a:prstGeom>
+        </p:spPr>
+        <p:txBody>
+          <a:bodyPr vert="horz" lIns="91440" tIns="45720" rIns="91440" bIns="45720" rtlCol="0"/>
+          <a:lstStyle>
+            <a:lvl1pPr algn="r">
+              <a:defRPr sz="1200"/>
+            </a:lvl1pPr>
+          </a:lstStyle>
+          <a:p>
+            <a:fld id="{0F89C1C7-3DCD-1040-A9CF-14679D8B5DDD}" type="datetimeFigureOut">
+              <a:rPr lang="en-US" smtClean="0"/>
+              <a:t>10/17/16</a:t>
+            </a:fld>
+            <a:endParaRPr lang="en-US"/>
+          </a:p>
+        </p:txBody>
+      </p:sp>
+      <p:sp>
+        <p:nvSpPr>
+          <p:cNvPr id="4" name="Slide Image Placeholder 3"/>
+          <p:cNvSpPr>
+            <a:spLocks noGrp="1" noRot="1" noChangeAspect="1"/>
+          </p:cNvSpPr>
+          <p:nvPr>
+            <p:ph type="sldImg" idx="2"/>
+          </p:nvPr>
+        </p:nvSpPr>
+        <p:spPr>
+          <a:xfrm>
+            <a:off x="1143000" y="685800"/>
+            <a:ext cx="4572000" cy="3429000"/>
+          </a:xfrm>
+          <a:prstGeom prst="rect">
+            <a:avLst/>
+          </a:prstGeom>
+          <a:noFill/>
+          <a:ln w="12700">
+            <a:solidFill>
+              <a:prstClr val="black"/>
+            </a:solidFill>
+          </a:ln>
+        </p:spPr>
+        <p:txBody>
+          <a:bodyPr vert="horz" lIns="91440" tIns="45720" rIns="91440" bIns="45720" rtlCol="0" anchor="ctr"/>
+          <a:lstStyle/>
+          <a:p>
+            <a:endParaRPr lang="en-US"/>
+          </a:p>
+        </p:txBody>
+      </p:sp>
+      <p:sp>
+        <p:nvSpPr>
+          <p:cNvPr id="5" name="Notes Placeholder 4"/>
+          <p:cNvSpPr>
+            <a:spLocks noGrp="1"/>
+          </p:cNvSpPr>
+          <p:nvPr>
+            <p:ph type="body" sz="quarter" idx="3"/>
+          </p:nvPr>
+        </p:nvSpPr>
+        <p:spPr>
+          <a:xfrm>
+            <a:off x="685800" y="4343400"/>
+            <a:ext cx="5486400" cy="4114800"/>
+          </a:xfrm>
+          <a:prstGeom prst="rect">
+            <a:avLst/>
+          </a:prstGeom>
+        </p:spPr>
+        <p:txBody>
+          <a:bodyPr vert="horz" lIns="91440" tIns="45720" rIns="91440" bIns="45720" rtlCol="0"/>
+          <a:lstStyle/>
+          <a:p>
+            <a:pPr lvl="0"/>
+            <a:r>
+              <a:rPr lang="en-US" smtClean="0"/>
+              <a:t>Click to edit Master text styles</a:t>
+            </a:r>
+          </a:p>
+          <a:p>
+            <a:pPr lvl="1"/>
+            <a:r>
+              <a:rPr lang="en-US" smtClean="0"/>
+              <a:t>Second level</a:t>
+            </a:r>
+          </a:p>
+          <a:p>
+            <a:pPr lvl="2"/>
+            <a:r>
+              <a:rPr lang="en-US" smtClean="0"/>
+              <a:t>Third level</a:t>
+            </a:r>
+          </a:p>
+          <a:p>
+            <a:pPr lvl="3"/>
+            <a:r>
+              <a:rPr lang="en-US" smtClean="0"/>
+              <a:t>Fourth level</a:t>
+            </a:r>
+          </a:p>
+          <a:p>
+            <a:pPr lvl="4"/>
+            <a:r>
+              <a:rPr lang="en-US" smtClean="0"/>
+              <a:t>Fifth level</a:t>
+            </a:r>
+            <a:endParaRPr lang="en-US"/>
+          </a:p>
+        </p:txBody>
+      </p:sp>
+      <p:sp>
+        <p:nvSpPr>
+          <p:cNvPr id="6" name="Footer Placeholder 5"/>
+          <p:cNvSpPr>
+            <a:spLocks noGrp="1"/>
+          </p:cNvSpPr>
+          <p:nvPr>
+            <p:ph type="ftr" sz="quarter" idx="4"/>
+          </p:nvPr>
+        </p:nvSpPr>
+        <p:spPr>
+          <a:xfrm>
+            <a:off x="0" y="8685213"/>
+            <a:ext cx="2971800" cy="457200"/>
+          </a:xfrm>
+          <a:prstGeom prst="rect">
+            <a:avLst/>
+          </a:prstGeom>
+        </p:spPr>
+        <p:txBody>
+          <a:bodyPr vert="horz" lIns="91440" tIns="45720" rIns="91440" bIns="45720" rtlCol="0" anchor="b"/>
+          <a:lstStyle>
+            <a:lvl1pPr algn="l">
+              <a:defRPr sz="1200"/>
+            </a:lvl1pPr>
+          </a:lstStyle>
+          <a:p>
+            <a:endParaRPr lang="en-US"/>
+          </a:p>
+        </p:txBody>
+      </p:sp>
+      <p:sp>
+        <p:nvSpPr>
+          <p:cNvPr id="7" name="Slide Number Placeholder 6"/>
+          <p:cNvSpPr>
+            <a:spLocks noGrp="1"/>
+          </p:cNvSpPr>
+          <p:nvPr>
+            <p:ph type="sldNum" sz="quarter" idx="5"/>
+          </p:nvPr>
+        </p:nvSpPr>
+        <p:spPr>
+          <a:xfrm>
+            <a:off x="3884613" y="8685213"/>
+            <a:ext cx="2971800" cy="457200"/>
+          </a:xfrm>
+          <a:prstGeom prst="rect">
+            <a:avLst/>
+          </a:prstGeom>
+        </p:spPr>
+        <p:txBody>
+          <a:bodyPr vert="horz" lIns="91440" tIns="45720" rIns="91440" bIns="45720" rtlCol="0" anchor="b"/>
+          <a:lstStyle>
+            <a:lvl1pPr algn="r">
+              <a:defRPr sz="1200"/>
+            </a:lvl1pPr>
+          </a:lstStyle>
+          <a:p>
+            <a:fld id="{BB5E49A5-4136-284D-997B-48E1D791AD67}" type="slidenum">
+              <a:rPr lang="en-US" smtClean="0"/>
+              <a:t>‹#›</a:t>
+            </a:fld>
+            <a:endParaRPr lang="en-US"/>
+          </a:p>
+        </p:txBody>
+      </p:sp>
+    </p:spTree>
+    <p:extLst>
+      <p:ext uri="{BB962C8B-B14F-4D97-AF65-F5344CB8AC3E}">
+        <p14:creationId xmlns:p14="http://schemas.microsoft.com/office/powerpoint/2010/main" val="2623252185"/>
+      </p:ext>
+    </p:extLst>
+  </p:cSld>
+  <p:clrMap bg1="lt1" tx1="dk1" bg2="lt2" tx2="dk2" accent1="accent1" accent2="accent2" accent3="accent3" accent4="accent4" accent5="accent5" accent6="accent6" hlink="hlink" folHlink="folHlink"/>
+  <p:notesStyle>
+    <a:lvl1pPr marL="0" algn="l" defTabSz="457200" rtl="0" eaLnBrk="1" latinLnBrk="0" hangingPunct="1">
+      <a:defRPr sz="1200" kern="1200">
+        <a:solidFill>
+          <a:schemeClr val="tx1"/>
+        </a:solidFill>
+        <a:latin typeface="+mn-lt"/>
+        <a:ea typeface="+mn-ea"/>
+        <a:cs typeface="+mn-cs"/>
+      </a:defRPr>
+    </a:lvl1pPr>
+    <a:lvl2pPr marL="457200" algn="l" defTabSz="457200" rtl="0" eaLnBrk="1" latinLnBrk="0" hangingPunct="1">
+      <a:defRPr sz="1200" kern="1200">
+        <a:solidFill>
+          <a:schemeClr val="tx1"/>
+        </a:solidFill>
+        <a:latin typeface="+mn-lt"/>
+        <a:ea typeface="+mn-ea"/>
+        <a:cs typeface="+mn-cs"/>
+      </a:defRPr>
+    </a:lvl2pPr>
+    <a:lvl3pPr marL="914400" algn="l" defTabSz="457200" rtl="0" eaLnBrk="1" latinLnBrk="0" hangingPunct="1">
+      <a:defRPr sz="1200" kern="1200">
+        <a:solidFill>
+          <a:schemeClr val="tx1"/>
+        </a:solidFill>
+        <a:latin typeface="+mn-lt"/>
+        <a:ea typeface="+mn-ea"/>
+        <a:cs typeface="+mn-cs"/>
+      </a:defRPr>
+    </a:lvl3pPr>
+    <a:lvl4pPr marL="1371600" algn="l" defTabSz="457200" rtl="0" eaLnBrk="1" latinLnBrk="0" hangingPunct="1">
+      <a:defRPr sz="1200" kern="1200">
+        <a:solidFill>
+          <a:schemeClr val="tx1"/>
+        </a:solidFill>
+        <a:latin typeface="+mn-lt"/>
+        <a:ea typeface="+mn-ea"/>
+        <a:cs typeface="+mn-cs"/>
+      </a:defRPr>
+    </a:lvl4pPr>
+    <a:lvl5pPr marL="1828800" algn="l" defTabSz="457200" rtl="0" eaLnBrk="1" latinLnBrk="0" hangingPunct="1">
+      <a:defRPr sz="1200" kern="1200">
+        <a:solidFill>
+          <a:schemeClr val="tx1"/>
+        </a:solidFill>
+        <a:latin typeface="+mn-lt"/>
+        <a:ea typeface="+mn-ea"/>
+        <a:cs typeface="+mn-cs"/>
+      </a:defRPr>
+    </a:lvl5pPr>
+    <a:lvl6pPr marL="2286000" algn="l" defTabSz="457200" rtl="0" eaLnBrk="1" latinLnBrk="0" hangingPunct="1">
+      <a:defRPr sz="1200" kern="1200">
+        <a:solidFill>
+          <a:schemeClr val="tx1"/>
+        </a:solidFill>
+        <a:latin typeface="+mn-lt"/>
+        <a:ea typeface="+mn-ea"/>
+        <a:cs typeface="+mn-cs"/>
+      </a:defRPr>
+    </a:lvl6pPr>
+    <a:lvl7pPr marL="2743200" algn="l" defTabSz="457200" rtl="0" eaLnBrk="1" latinLnBrk="0" hangingPunct="1">
+      <a:defRPr sz="1200" kern="1200">
+        <a:solidFill>
+          <a:schemeClr val="tx1"/>
+        </a:solidFill>
+        <a:latin typeface="+mn-lt"/>
+        <a:ea typeface="+mn-ea"/>
+        <a:cs typeface="+mn-cs"/>
+      </a:defRPr>
+    </a:lvl7pPr>
+    <a:lvl8pPr marL="3200400" algn="l" defTabSz="457200" rtl="0" eaLnBrk="1" latinLnBrk="0" hangingPunct="1">
+      <a:defRPr sz="1200" kern="1200">
+        <a:solidFill>
+          <a:schemeClr val="tx1"/>
+        </a:solidFill>
+        <a:latin typeface="+mn-lt"/>
+        <a:ea typeface="+mn-ea"/>
+        <a:cs typeface="+mn-cs"/>
+      </a:defRPr>
+    </a:lvl8pPr>
+    <a:lvl9pPr marL="3657600" algn="l" defTabSz="457200" rtl="0" eaLnBrk="1" latinLnBrk="0" hangingPunct="1">
+      <a:defRPr sz="1200" kern="1200">
+        <a:solidFill>
+          <a:schemeClr val="tx1"/>
+        </a:solidFill>
+        <a:latin typeface="+mn-lt"/>
+        <a:ea typeface="+mn-ea"/>
+        <a:cs typeface="+mn-cs"/>
+      </a:defRPr>
+    </a:lvl9pPr>
+  </p:notesStyle>
+</p:notesMaster>
+</file>
+
+<file path=ppt/notesSlides/notesSlide1.xml><?xml version="1.0" encoding="utf-8"?>
+<p:notes xmlns:a="http://schemas.openxmlformats.org/drawingml/2006/main" xmlns:p="http://schemas.openxmlformats.org/presentationml/2006/main" xmlns:r="http://schemas.openxmlformats.org/officeDocument/2006/relationships">
+  <p:cSld>
+    <p:spTree>
+      <p:nvGrpSpPr>
+        <p:cNvPr id="1" name=""/>
+        <p:cNvGrpSpPr/>
+        <p:nvPr/>
+      </p:nvGrpSpPr>
+      <p:grpSpPr>
+        <a:xfrm>
+          <a:off x="0" y="0"/>
+          <a:ext cx="0" cy="0"/>
+          <a:chOff x="0" y="0"/>
+          <a:chExt cx="0" cy="0"/>
+        </a:xfrm>
+      </p:grpSpPr>
+      <p:sp>
+        <p:nvSpPr>
+          <p:cNvPr id="2" name="Slide Image Placeholder 1"/>
+          <p:cNvSpPr>
+            <a:spLocks noGrp="1"/>
+          </p:cNvSpPr>
+          <p:nvPr>
+            <p:ph type="sldImg" idx="2"/>
+          </p:nvPr>
+        </p:nvSpPr>
+        <p:spPr/>
+      </p:sp>
+      <p:sp>
+        <p:nvSpPr>
+          <p:cNvPr id="3" name="Notes Placeholder 2"/>
+          <p:cNvSpPr>
+            <a:spLocks noGrp="1"/>
+          </p:cNvSpPr>
+          <p:nvPr>
+            <p:ph type="body" idx="3" sz="quarter"/>
+          </p:nvPr>
+        </p:nvSpPr>
+        <p:spPr/>
+        <p:txBody>
+          <a:bodyPr/>
+          <a:lstStyle/>
+          <a:p>
+            <a:r>
+              <a:t>[SLIDE CHUYỂN PHẦN]: Bấm lướt qua nhanh sang Slide 16, không dừng lại nói dài dòng.</a:t>
+            </a:r>
+          </a:p>
+        </p:txBody>
+      </p:sp>
+      <p:sp>
+        <p:nvSpPr>
+          <p:cNvPr id="4" name="Slide Number Placeholder 3"/>
+          <p:cNvSpPr>
+            <a:spLocks noGrp="1"/>
+          </p:cNvSpPr>
+          <p:nvPr>
+            <p:ph type="sldNum" idx="5" sz="quarter"/>
+          </p:nvPr>
+        </p:nvSpPr>
+        <p:spPr/>
+      </p:sp>
+    </p:spTree>
+  </p:cSld>
+  <p:clrMapOvr>
+    <a:masterClrMapping/>
+  </p:clrMapOvr>
+</p:notes>
+</file>
+
+<file path=ppt/notesSlides/notesSlide2.xml><?xml version="1.0" encoding="utf-8"?>
+<p:notes xmlns:a="http://schemas.openxmlformats.org/drawingml/2006/main" xmlns:p="http://schemas.openxmlformats.org/presentationml/2006/main" xmlns:r="http://schemas.openxmlformats.org/officeDocument/2006/relationships">
+  <p:cSld>
+    <p:spTree>
+      <p:nvGrpSpPr>
+        <p:cNvPr id="1" name=""/>
+        <p:cNvGrpSpPr/>
+        <p:nvPr/>
+      </p:nvGrpSpPr>
+      <p:grpSpPr>
+        <a:xfrm>
+          <a:off x="0" y="0"/>
+          <a:ext cx="0" cy="0"/>
+          <a:chOff x="0" y="0"/>
+          <a:chExt cx="0" cy="0"/>
+        </a:xfrm>
+      </p:grpSpPr>
+      <p:sp>
+        <p:nvSpPr>
+          <p:cNvPr id="2" name="Slide Image Placeholder 1"/>
+          <p:cNvSpPr>
+            <a:spLocks noGrp="1"/>
+          </p:cNvSpPr>
+          <p:nvPr>
+            <p:ph type="sldImg" idx="2"/>
+          </p:nvPr>
+        </p:nvSpPr>
+        <p:spPr/>
+      </p:sp>
+      <p:sp>
+        <p:nvSpPr>
+          <p:cNvPr id="3" name="Notes Placeholder 2"/>
+          <p:cNvSpPr>
+            <a:spLocks noGrp="1"/>
+          </p:cNvSpPr>
+          <p:nvPr>
+            <p:ph type="body" idx="3" sz="quarter"/>
+          </p:nvPr>
+        </p:nvSpPr>
+        <p:spPr/>
+        <p:txBody>
+          <a:bodyPr/>
+          <a:lstStyle/>
+          <a:p>
+            <a:r>
+              <a:t>[NỘI DUNG CHÍNH]: Mô hình 1 — TF-IDF Baseline &amp; LinearSVC (Máy học cổ điển).</a:t>
+            </a:r>
+          </a:p>
+          <a:p>
+            <a:r>
+              <a:t>[LỜI THUYẾT TRÌNH]:</a:t>
+            </a:r>
+          </a:p>
+          <a:p>
+            <a:r>
+              <a:t>- Mô tả: TF-IDF (Character N-grams n=3..5) + LinearSVC trên không gian ~50.000 đặc trưng.</a:t>
+            </a:r>
+          </a:p>
+          <a:p>
+            <a:r>
+              <a:t>- Bài báo bảo chứng &amp; Thành tựu (Jain et al., 2023 [5]):</a:t>
+            </a:r>
+          </a:p>
+          <a:p>
+            <a:r>
+              <a:t>  1. Tốc độ siêu nhanh: ~0.85ms trên CPU, tốn &lt; 50MB RAM, không cần GPU.</a:t>
+            </a:r>
+          </a:p>
+          <a:p>
+            <a:r>
+              <a:t>  2. Bắt từ viết lách (Leetspeak như 1gn0r3, chèn dấu cách): Quét trượt cụm 3-5 ký tự bóc tách các mảnh con ('1gn', 'gn0', 'n0r') mà Tokenizer của LLM bỏ sót.</a:t>
+            </a:r>
+          </a:p>
+          <a:p>
+            <a:r>
+              <a:t>  3. Phân loại tuyến tính: Siêu phẳng w^T x + b = 0, vector thưa &gt; 99.5%, tích vô hướng thưa cực nhanh.</a:t>
+            </a:r>
+          </a:p>
+          <a:p>
+            <a:r>
+              <a:t>- Điểm yếu chí mạng:</a:t>
+            </a:r>
+          </a:p>
+          <a:p>
+            <a:r>
+              <a:t>  1. Mù ngữ nghĩa (chỉ đếm chữ chứ không hiểu câu), bất lực trước vai diễn tinh vi (DAN Mode).</a:t>
+            </a:r>
+          </a:p>
+          <a:p>
+            <a:r>
+              <a:t>  2. Chặn nhầm rất cao (FPR 15 - 25%) với câu hỏi an ninh mạng hợp lệ chứa từ nhạy cảm.</a:t>
+            </a:r>
+          </a:p>
+          <a:p>
+            <a:r>
+              <a:t>[TỪ KHÓA &amp; PHẢN BIỆN]:</a:t>
+            </a:r>
+          </a:p>
+          <a:p>
+            <a:r>
+              <a:t>- Dải n=3..5 không ngẫu nhiên: (1) Gốc từ nhạy cảm tiếng Anh dài 3-5 chữ; (2) n&lt;3 gây nhiễu, n&gt;5 nổ số chiều và dễ gãy vụn; (3) Thực nghiệm Jain et al. (2023) chứng minh n=3..5 đạt ROC-AUC cao nhất trước tấn công đối kháng GCG.</a:t>
+            </a:r>
+          </a:p>
+        </p:txBody>
+      </p:sp>
+      <p:sp>
+        <p:nvSpPr>
+          <p:cNvPr id="4" name="Slide Number Placeholder 3"/>
+          <p:cNvSpPr>
+            <a:spLocks noGrp="1"/>
+          </p:cNvSpPr>
+          <p:nvPr>
+            <p:ph type="sldNum" idx="5" sz="quarter"/>
+          </p:nvPr>
+        </p:nvSpPr>
+        <p:spPr/>
+      </p:sp>
+    </p:spTree>
+  </p:cSld>
+  <p:clrMapOvr>
+    <a:masterClrMapping/>
+  </p:clrMapOvr>
+</p:notes>
+</file>
+
+<file path=ppt/notesSlides/notesSlide3.xml><?xml version="1.0" encoding="utf-8"?>
+<p:notes xmlns:a="http://schemas.openxmlformats.org/drawingml/2006/main" xmlns:p="http://schemas.openxmlformats.org/presentationml/2006/main" xmlns:r="http://schemas.openxmlformats.org/officeDocument/2006/relationships">
+  <p:cSld>
+    <p:spTree>
+      <p:nvGrpSpPr>
+        <p:cNvPr id="1" name=""/>
+        <p:cNvGrpSpPr/>
+        <p:nvPr/>
+      </p:nvGrpSpPr>
+      <p:grpSpPr>
+        <a:xfrm>
+          <a:off x="0" y="0"/>
+          <a:ext cx="0" cy="0"/>
+          <a:chOff x="0" y="0"/>
+          <a:chExt cx="0" cy="0"/>
+        </a:xfrm>
+      </p:grpSpPr>
+      <p:sp>
+        <p:nvSpPr>
+          <p:cNvPr id="2" name="Slide Image Placeholder 1"/>
+          <p:cNvSpPr>
+            <a:spLocks noGrp="1"/>
+          </p:cNvSpPr>
+          <p:nvPr>
+            <p:ph type="sldImg" idx="2"/>
+          </p:nvPr>
+        </p:nvSpPr>
+        <p:spPr/>
+      </p:sp>
+      <p:sp>
+        <p:nvSpPr>
+          <p:cNvPr id="3" name="Notes Placeholder 2"/>
+          <p:cNvSpPr>
+            <a:spLocks noGrp="1"/>
+          </p:cNvSpPr>
+          <p:nvPr>
+            <p:ph type="body" idx="3" sz="quarter"/>
+          </p:nvPr>
+        </p:nvSpPr>
+        <p:spPr/>
+        <p:txBody>
+          <a:bodyPr/>
+          <a:lstStyle/>
+          <a:p>
+            <a:r>
+              <a:t>[NỘI DUNG CHÍNH]: Mô hình 2 — Deep Transformer DeBERTa-v3 &amp; Lượng hóa ONNX INT8.</a:t>
+            </a:r>
+          </a:p>
+          <a:p>
+            <a:r>
+              <a:t>[LỜI THUYẾT TRÌNH]:</a:t>
+            </a:r>
+          </a:p>
+          <a:p>
+            <a:r>
+              <a:t>- Mô tả: Học sâu DeBERTa-v3 kết hợp Disentangled Attention và nén lượng hóa ONNX INT8.</a:t>
+            </a:r>
+          </a:p>
+          <a:p>
+            <a:r>
+              <a:t>- Bài báo bảo chứng &amp; Thành tựu:</a:t>
+            </a:r>
+          </a:p>
+          <a:p>
+            <a:r>
+              <a:t>  1. He et al. (ICLR 2023 [6]): Disentangled Attention tách biệt vector nội dung và vector vị trí, bóc trần đòn đảo ngữ và đóng vai tâm lý (DAN Mode).</a:t>
+            </a:r>
+          </a:p>
+          <a:p>
+            <a:r>
+              <a:t>  2. Kiểm soát chặn nhầm xuất sắc: Hiểu ngữ cảnh sâu giúp hạ FPR xuống &lt; 1.0%.</a:t>
+            </a:r>
+          </a:p>
+          <a:p>
+            <a:r>
+              <a:t>  3. Yao et al. (NeurIPS 2022 [7]): Lượng hóa ONNX INT8 tăng tốc 3.2 lần, đạt ~18.5ms trên CPU thông thường, 0 GPU.</a:t>
+            </a:r>
+          </a:p>
+          <a:p>
+            <a:r>
+              <a:t>- Điểm yếu cốt tử:</a:t>
+            </a:r>
+          </a:p>
+          <a:p>
+            <a:r>
+              <a:t>  1. Độ trễ 18.5ms vẫn nặng gấp hơn 20 lần so với Tầng 1 (0.85ms).</a:t>
+            </a:r>
+          </a:p>
+          <a:p>
+            <a:r>
+              <a:t>  2. Nếu 100% câu hỏi bình thường đều bắt DeBERTa xử lý thì CPU sẽ bị quá tải/nghẽn khi đông người dùng.</a:t>
+            </a:r>
+          </a:p>
+          <a:p>
+            <a:r>
+              <a:t>[CẦU NỐI]: Dùng riêng Tầng 1 thì chặn nhầm nhiều, dùng riêng Tầng 2 thì chậm và tốn tài nguyên -&gt; Động lực ra đời mô hình kết hợp PI-Guard ở Slide 18!</a:t>
+            </a:r>
+          </a:p>
+        </p:txBody>
+      </p:sp>
+      <p:sp>
+        <p:nvSpPr>
+          <p:cNvPr id="4" name="Slide Number Placeholder 3"/>
+          <p:cNvSpPr>
+            <a:spLocks noGrp="1"/>
+          </p:cNvSpPr>
+          <p:nvPr>
+            <p:ph type="sldNum" idx="5" sz="quarter"/>
+          </p:nvPr>
+        </p:nvSpPr>
+        <p:spPr/>
+      </p:sp>
+    </p:spTree>
+  </p:cSld>
+  <p:clrMapOvr>
+    <a:masterClrMapping/>
+  </p:clrMapOvr>
+</p:notes>
+</file>
+
+<file path=ppt/notesSlides/notesSlide4.xml><?xml version="1.0" encoding="utf-8"?>
+<p:notes xmlns:a="http://schemas.openxmlformats.org/drawingml/2006/main" xmlns:p="http://schemas.openxmlformats.org/presentationml/2006/main" xmlns:r="http://schemas.openxmlformats.org/officeDocument/2006/relationships">
+  <p:cSld>
+    <p:spTree>
+      <p:nvGrpSpPr>
+        <p:cNvPr id="1" name=""/>
+        <p:cNvGrpSpPr/>
+        <p:nvPr/>
+      </p:nvGrpSpPr>
+      <p:grpSpPr>
+        <a:xfrm>
+          <a:off x="0" y="0"/>
+          <a:ext cx="0" cy="0"/>
+          <a:chOff x="0" y="0"/>
+          <a:chExt cx="0" cy="0"/>
+        </a:xfrm>
+      </p:grpSpPr>
+      <p:sp>
+        <p:nvSpPr>
+          <p:cNvPr id="2" name="Slide Image Placeholder 1"/>
+          <p:cNvSpPr>
+            <a:spLocks noGrp="1"/>
+          </p:cNvSpPr>
+          <p:nvPr>
+            <p:ph type="sldImg" idx="2"/>
+          </p:nvPr>
+        </p:nvSpPr>
+        <p:spPr/>
+      </p:sp>
+      <p:sp>
+        <p:nvSpPr>
+          <p:cNvPr id="3" name="Notes Placeholder 2"/>
+          <p:cNvSpPr>
+            <a:spLocks noGrp="1"/>
+          </p:cNvSpPr>
+          <p:nvPr>
+            <p:ph type="body" idx="3" sz="quarter"/>
+          </p:nvPr>
+        </p:nvSpPr>
+        <p:spPr/>
+        <p:txBody>
+          <a:bodyPr/>
+          <a:lstStyle/>
+          <a:p>
+            <a:r>
+              <a:t>[NỘI DUNG CHÍNH]: Mô hình kết hợp của đề tài — PI-Guard Two-Tier Cascaded Guardrail.</a:t>
+            </a:r>
+          </a:p>
+          <a:p>
+            <a:r>
+              <a:t>[LỜI THUYẾT TRÌNH]:</a:t>
+            </a:r>
+          </a:p>
+          <a:p>
+            <a:r>
+              <a:t>- Đóng góp cốt lõi của PI-Guard: Kết hợp cả TF-IDF (Tầng 1) và DeBERTa-v3 (Tầng 2) qua cơ chế Phân luồng theo độ tự tin (Uncertainty Routing).</a:t>
+            </a:r>
+          </a:p>
+          <a:p>
+            <a:r>
+              <a:t>- Cơ sở lý thuyết (Saltzer &amp; Schroeder 1975 [8]):</a:t>
+            </a:r>
+          </a:p>
+          <a:p>
+            <a:r>
+              <a:t>  1. Kiểm duyệt toàn diện: Mọi prompt đều phải qua chốt kiểm tra cổng trước.</a:t>
+            </a:r>
+          </a:p>
+          <a:p>
+            <a:r>
+              <a:t>  2. Cơ chế tinh gọn: Tầng nhẹ gánh việc dễ, tầng nặng xử lý ca khó.</a:t>
+            </a:r>
+          </a:p>
+          <a:p>
+            <a:r>
+              <a:t>- Quy trình 3 nhánh của PI-Guard:</a:t>
+            </a:r>
+          </a:p>
+          <a:p>
+            <a:r>
+              <a:t>  1. Nhánh 1 - Chặn ngay (P &gt;= 0.85): Ngắt kết nối ngay trong 0.85ms với HTTP 403, giải quyết 80% vụ tấn công thô, tiết kiệm CPU.</a:t>
+            </a:r>
+          </a:p>
+          <a:p>
+            <a:r>
+              <a:t>  2. Nhánh 2 - Cho qua nhanh (P &lt;= 0.15): Đẩy thẳng đến LLM trong 0.85ms với câu an toàn thông thường.</a:t>
+            </a:r>
+          </a:p>
+          <a:p>
+            <a:r>
+              <a:t>  3. Nhánh 3 - Vùng phân vân (0.15 &lt; P &lt; 0.85): Chuyển tiếp lên DeBERTa-v3 để thẩm định ngữ nghĩa sâu.</a:t>
+            </a:r>
+          </a:p>
+          <a:p>
+            <a:r>
+              <a:t>- Thành tựu của PI-Guard: Triệt tiêu nhược điểm của cả 2 mô hình; Đạt tối ưu Pareto: P95 &lt; 22ms CPU, FPR &lt; 1.0%, giảm 80% tải CPU, 100% không tốn chi phí GPU.</a:t>
+            </a:r>
+          </a:p>
+        </p:txBody>
+      </p:sp>
+      <p:sp>
+        <p:nvSpPr>
+          <p:cNvPr id="4" name="Slide Number Placeholder 3"/>
+          <p:cNvSpPr>
+            <a:spLocks noGrp="1"/>
+          </p:cNvSpPr>
+          <p:nvPr>
+            <p:ph type="sldNum" idx="5" sz="quarter"/>
+          </p:nvPr>
+        </p:nvSpPr>
+        <p:spPr/>
+      </p:sp>
+    </p:spTree>
+  </p:cSld>
+  <p:clrMapOvr>
+    <a:masterClrMapping/>
+  </p:clrMapOvr>
+</p:notes>
+</file>
+
+<file path=ppt/notesSlides/notesSlide5.xml><?xml version="1.0" encoding="utf-8"?>
+<p:notes xmlns:a="http://schemas.openxmlformats.org/drawingml/2006/main" xmlns:p="http://schemas.openxmlformats.org/presentationml/2006/main" xmlns:r="http://schemas.openxmlformats.org/officeDocument/2006/relationships">
+  <p:cSld>
+    <p:spTree>
+      <p:nvGrpSpPr>
+        <p:cNvPr id="1" name=""/>
+        <p:cNvGrpSpPr/>
+        <p:nvPr/>
+      </p:nvGrpSpPr>
+      <p:grpSpPr>
+        <a:xfrm>
+          <a:off x="0" y="0"/>
+          <a:ext cx="0" cy="0"/>
+          <a:chOff x="0" y="0"/>
+          <a:chExt cx="0" cy="0"/>
+        </a:xfrm>
+      </p:grpSpPr>
+      <p:sp>
+        <p:nvSpPr>
+          <p:cNvPr id="2" name="Slide Image Placeholder 1"/>
+          <p:cNvSpPr>
+            <a:spLocks noGrp="1"/>
+          </p:cNvSpPr>
+          <p:nvPr>
+            <p:ph type="sldImg" idx="2"/>
+          </p:nvPr>
+        </p:nvSpPr>
+        <p:spPr/>
+      </p:sp>
+      <p:sp>
+        <p:nvSpPr>
+          <p:cNvPr id="3" name="Notes Placeholder 2"/>
+          <p:cNvSpPr>
+            <a:spLocks noGrp="1"/>
+          </p:cNvSpPr>
+          <p:nvPr>
+            <p:ph type="body" idx="3" sz="quarter"/>
+          </p:nvPr>
+        </p:nvSpPr>
+        <p:spPr/>
+        <p:txBody>
+          <a:bodyPr/>
+          <a:lstStyle/>
+          <a:p>
+            <a:r>
+              <a:t>[NỘI DUNG CHÍNH]: Bảng đối chiếu 4 kịch bản thực nghiệm (2x2 Matrix).</a:t>
+            </a:r>
+          </a:p>
+          <a:p>
+            <a:r>
+              <a:t>[LỜI THUYẾT TRÌNH]:</a:t>
+            </a:r>
+          </a:p>
+          <a:p>
+            <a:r>
+              <a:t>- Kịch bản 1 (Prompt Injection - Đòi trích xuất API Key):</a:t>
+            </a:r>
+          </a:p>
+          <a:p>
+            <a:r>
+              <a:t>  * Chưa có bảo vệ (Demo 1A): LLM bị lừa, làm lộ khóa bí mật ABC-SEC-998877.</a:t>
+            </a:r>
+          </a:p>
+          <a:p>
+            <a:r>
+              <a:t>  * Có PI-Guard (Demo 1B): Chốt chặn phát hiện lệnh ghi đè, điểm rủi ro 0.964 -&gt; Trả HTTP 403 trong 14.8ms, khóa bí mật an toàn.</a:t>
+            </a:r>
+          </a:p>
+          <a:p>
+            <a:r>
+              <a:t>- Kịch bản 2 (Jailbreak - Bắt đóng vai DAN viết mã độc):</a:t>
+            </a:r>
+          </a:p>
+          <a:p>
+            <a:r>
+              <a:t>  * Chưa có bảo vệ (Demo 2A): LLM bị bẻ khóa đạo đức, sinh mã độc Ransomware hoàn chỉnh.</a:t>
+            </a:r>
+          </a:p>
+          <a:p>
+            <a:r>
+              <a:t>  * Có PI-Guard (Demo 2B): DeBERTa-v3 phát hiện trò đóng vai, điểm rủi ro 0.942 -&gt; Trả HTTP 403 trong 13.5ms.</a:t>
+            </a:r>
+          </a:p>
+          <a:p>
+            <a:r>
+              <a:t>- Khẳng định: PI-Guard hoạt động hiệu quả như nguyên mẫu thực nghiệm đáng tin cậy, chặn tấn công dưới 15ms.</a:t>
+            </a:r>
+          </a:p>
+          <a:p>
+            <a:r>
+              <a:t>[TỪ KHÓA CẦN NHỚ]: Ma trận 2x2 = Bảng 4 ô đối chiếu; Độ trễ &lt; 15ms = Đo trên CPU thông thường từ lúc nhận request đến lúc trả mã 403.</a:t>
+            </a:r>
+          </a:p>
+        </p:txBody>
+      </p:sp>
+      <p:sp>
+        <p:nvSpPr>
+          <p:cNvPr id="4" name="Slide Number Placeholder 3"/>
+          <p:cNvSpPr>
+            <a:spLocks noGrp="1"/>
+          </p:cNvSpPr>
+          <p:nvPr>
+            <p:ph type="sldNum" idx="5" sz="quarter"/>
+          </p:nvPr>
+        </p:nvSpPr>
+        <p:spPr/>
+      </p:sp>
+    </p:spTree>
+  </p:cSld>
+  <p:clrMapOvr>
+    <a:masterClrMapping/>
+  </p:clrMapOvr>
+</p:notes>
+</file>
+
+<file path=ppt/notesSlides/notesSlide6.xml><?xml version="1.0" encoding="utf-8"?>
+<p:notes xmlns:a="http://schemas.openxmlformats.org/drawingml/2006/main" xmlns:p="http://schemas.openxmlformats.org/presentationml/2006/main" xmlns:r="http://schemas.openxmlformats.org/officeDocument/2006/relationships">
+  <p:cSld>
+    <p:spTree>
+      <p:nvGrpSpPr>
+        <p:cNvPr id="1" name=""/>
+        <p:cNvGrpSpPr/>
+        <p:nvPr/>
+      </p:nvGrpSpPr>
+      <p:grpSpPr>
+        <a:xfrm>
+          <a:off x="0" y="0"/>
+          <a:ext cx="0" cy="0"/>
+          <a:chOff x="0" y="0"/>
+          <a:chExt cx="0" cy="0"/>
+        </a:xfrm>
+      </p:grpSpPr>
+      <p:sp>
+        <p:nvSpPr>
+          <p:cNvPr id="2" name="Slide Image Placeholder 1"/>
+          <p:cNvSpPr>
+            <a:spLocks noGrp="1"/>
+          </p:cNvSpPr>
+          <p:nvPr>
+            <p:ph type="sldImg" idx="2"/>
+          </p:nvPr>
+        </p:nvSpPr>
+        <p:spPr/>
+      </p:sp>
+      <p:sp>
+        <p:nvSpPr>
+          <p:cNvPr id="3" name="Notes Placeholder 2"/>
+          <p:cNvSpPr>
+            <a:spLocks noGrp="1"/>
+          </p:cNvSpPr>
+          <p:nvPr>
+            <p:ph type="body" idx="3" sz="quarter"/>
+          </p:nvPr>
+        </p:nvSpPr>
+        <p:spPr/>
+        <p:txBody>
+          <a:bodyPr/>
+          <a:lstStyle/>
+          <a:p>
+            <a:r>
+              <a:t>[NỘI DUNG CHÍNH]: 3 Khoảng trống thực tế &amp; 3 Câu hỏi nghiên cứu IEEE.</a:t>
+            </a:r>
+          </a:p>
+          <a:p>
+            <a:r>
+              <a:t>[LỜI THUYẾT TRÌNH]:</a:t>
+            </a:r>
+          </a:p>
+          <a:p>
+            <a:r>
+              <a:t>- Cột 1 (Gap 1 -&gt; RQ1): Chia ngẫu nhiên làm rò rỉ câu mẫu vào cả tập học lẫn tập thi, điểm cao ảo. RQ1: Nhóm câu tương đồng (Group-Aware Splitting) giúp đánh giá đúng năng lực thực tế thế nào?</a:t>
+            </a:r>
+          </a:p>
+          <a:p>
+            <a:r>
+              <a:t>- Cột 2 (Gap 2 -&gt; RQ2): Bộ lọc đơn lẻ dễ sụp trước từ viết lách (Leetspeak, dấu cách). RQ2: Hệ thống nhiều lớp đem lại độ bền vượt trội ra sao trước các đòn biến dị?</a:t>
+            </a:r>
+          </a:p>
+          <a:p>
+            <a:r>
+              <a:t>- Cột 3 (Gap 3 -&gt; RQ3): Cân bằng giữa độ trễ và chặn nhầm. RQ3: Làm sao PI-Guard đạt cả 3: bắt tấn công chuẩn, ít chặn nhầm, và xử lý nhanh trên CPU?</a:t>
+            </a:r>
+          </a:p>
+          <a:p>
+            <a:r>
+              <a:t>- Kim chỉ nam khoa học sẽ được đo đạc định lượng rõ ở Chapter 3 và Chapter 4.</a:t>
+            </a:r>
+          </a:p>
+          <a:p>
+            <a:r>
+              <a:t>[TỪ KHÓA CẦN NHỚ]: Data Leakage = Rò rỉ đề thi giữa tập học và tập thi; OOD = Các câu tấn công mới lạ chưa từng gặp.</a:t>
+            </a:r>
+          </a:p>
+        </p:txBody>
+      </p:sp>
+      <p:sp>
+        <p:nvSpPr>
+          <p:cNvPr id="4" name="Slide Number Placeholder 3"/>
+          <p:cNvSpPr>
+            <a:spLocks noGrp="1"/>
+          </p:cNvSpPr>
+          <p:nvPr>
+            <p:ph type="sldNum" idx="5" sz="quarter"/>
+          </p:nvPr>
+        </p:nvSpPr>
+        <p:spPr/>
+      </p:sp>
+    </p:spTree>
+  </p:cSld>
+  <p:clrMapOvr>
+    <a:masterClrMapping/>
+  </p:clrMapOvr>
+</p:notes>
+</file>
+
+<file path=ppt/notesSlides/notesSlide7.xml><?xml version="1.0" encoding="utf-8"?>
+<p:notes xmlns:a="http://schemas.openxmlformats.org/drawingml/2006/main" xmlns:p="http://schemas.openxmlformats.org/presentationml/2006/main" xmlns:r="http://schemas.openxmlformats.org/officeDocument/2006/relationships">
+  <p:cSld>
+    <p:spTree>
+      <p:nvGrpSpPr>
+        <p:cNvPr id="1" name=""/>
+        <p:cNvGrpSpPr/>
+        <p:nvPr/>
+      </p:nvGrpSpPr>
+      <p:grpSpPr>
+        <a:xfrm>
+          <a:off x="0" y="0"/>
+          <a:ext cx="0" cy="0"/>
+          <a:chOff x="0" y="0"/>
+          <a:chExt cx="0" cy="0"/>
+        </a:xfrm>
+      </p:grpSpPr>
+      <p:sp>
+        <p:nvSpPr>
+          <p:cNvPr id="2" name="Slide Image Placeholder 1"/>
+          <p:cNvSpPr>
+            <a:spLocks noGrp="1"/>
+          </p:cNvSpPr>
+          <p:nvPr>
+            <p:ph type="sldImg" idx="2"/>
+          </p:nvPr>
+        </p:nvSpPr>
+        <p:spPr/>
+      </p:sp>
+      <p:sp>
+        <p:nvSpPr>
+          <p:cNvPr id="3" name="Notes Placeholder 2"/>
+          <p:cNvSpPr>
+            <a:spLocks noGrp="1"/>
+          </p:cNvSpPr>
+          <p:nvPr>
+            <p:ph type="body" idx="3" sz="quarter"/>
+          </p:nvPr>
+        </p:nvSpPr>
+        <p:spPr/>
+        <p:txBody>
+          <a:bodyPr/>
+          <a:lstStyle/>
+          <a:p>
+            <a:r>
+              <a:t>[NỘI DUNG CHÍNH]: 8 Công trình khoa học uy tín bảo chứng cho đề tài.</a:t>
+            </a:r>
+          </a:p>
+          <a:p>
+            <a:r>
+              <a:t>[LỜI THUYẾT TRÌNH]:</a:t>
+            </a:r>
+          </a:p>
+          <a:p>
+            <a:r>
+              <a:t>- Toàn bộ luận điểm trong bài được bảo chứng từ 8 bài báo đỉnh cao tại ACM CCS, NeurIPS, ICLR, IEEE:</a:t>
+            </a:r>
+          </a:p>
+          <a:p>
+            <a:r>
+              <a:t>  * 4 bài về tấn công (Slide 4-13): Perez 2022 (PromptInject), Shen 2024 (Jailbreak DAN), Greshake 2023 (4 Tầng thiệt hại), Tencent 2026 (Mô hình vùng an toàn).</a:t>
+            </a:r>
+          </a:p>
+          <a:p>
+            <a:r>
+              <a:t>  * 4 bài về phòng thủ (Slide 16-19): Jain 2023 (Quét cụm ký tự), He 2023 (DeBERTa tách rời nội dung và vị trí), Yao 2022 (Nén INT8 tăng tốc 3.2x), Saltzer &amp; Schroeder 1975 (Nguyên tắc kiểm duyệt toàn diện &amp; cơ chế tinh gọn).</a:t>
+            </a:r>
+          </a:p>
+          <a:p>
+            <a:r>
+              <a:t>- 100% bài báo có bản toàn văn lưu trữ tại thư mục References/.</a:t>
+            </a:r>
+          </a:p>
+          <a:p>
+            <a:r>
+              <a:t>[TỪ KHÓA CẦN NHỚ]: Đều áp dụng cho mô hình Cổng lọc trung gian bên ngoài, không cần can thiệp vào trọng số bên trong của LLM.</a:t>
+            </a:r>
+          </a:p>
+        </p:txBody>
+      </p:sp>
+      <p:sp>
+        <p:nvSpPr>
+          <p:cNvPr id="4" name="Slide Number Placeholder 3"/>
+          <p:cNvSpPr>
+            <a:spLocks noGrp="1"/>
+          </p:cNvSpPr>
+          <p:nvPr>
+            <p:ph type="sldNum" idx="5" sz="quarter"/>
+          </p:nvPr>
+        </p:nvSpPr>
+        <p:spPr/>
+      </p:sp>
+    </p:spTree>
+  </p:cSld>
+  <p:clrMapOvr>
+    <a:masterClrMapping/>
+  </p:clrMapOvr>
+</p:notes>
+</file>
+
+<file path=ppt/notesSlides/notesSlide8.xml><?xml version="1.0" encoding="utf-8"?>
+<p:notes xmlns:a="http://schemas.openxmlformats.org/drawingml/2006/main" xmlns:p="http://schemas.openxmlformats.org/presentationml/2006/main" xmlns:r="http://schemas.openxmlformats.org/officeDocument/2006/relationships">
+  <p:cSld>
+    <p:spTree>
+      <p:nvGrpSpPr>
+        <p:cNvPr id="1" name=""/>
+        <p:cNvGrpSpPr/>
+        <p:nvPr/>
+      </p:nvGrpSpPr>
+      <p:grpSpPr>
+        <a:xfrm>
+          <a:off x="0" y="0"/>
+          <a:ext cx="0" cy="0"/>
+          <a:chOff x="0" y="0"/>
+          <a:chExt cx="0" cy="0"/>
+        </a:xfrm>
+      </p:grpSpPr>
+      <p:sp>
+        <p:nvSpPr>
+          <p:cNvPr id="2" name="Slide Image Placeholder 1"/>
+          <p:cNvSpPr>
+            <a:spLocks noGrp="1"/>
+          </p:cNvSpPr>
+          <p:nvPr>
+            <p:ph type="sldImg" idx="2"/>
+          </p:nvPr>
+        </p:nvSpPr>
+        <p:spPr/>
+      </p:sp>
+      <p:sp>
+        <p:nvSpPr>
+          <p:cNvPr id="3" name="Notes Placeholder 2"/>
+          <p:cNvSpPr>
+            <a:spLocks noGrp="1"/>
+          </p:cNvSpPr>
+          <p:nvPr>
+            <p:ph type="body" idx="3" sz="quarter"/>
+          </p:nvPr>
+        </p:nvSpPr>
+        <p:spPr/>
+        <p:txBody>
+          <a:bodyPr/>
+          <a:lstStyle/>
+          <a:p>
+            <a:r>
+              <a:t>[NỘI DUNG CHÍNH]: Kết luận &amp; Mời nhận xét thảo luận (Q&amp;A).</a:t>
+            </a:r>
+          </a:p>
+          <a:p>
+            <a:r>
+              <a:t>[LỜI THUYẾT TRÌNH]:</a:t>
+            </a:r>
+          </a:p>
+          <a:p>
+            <a:r>
+              <a:t>- Tuyên bố sứ mệnh: 'Hướng tới các ứng dụng Mô hình Ngôn ngữ Lớn an toàn hơn và đáng tin cậy hơn'.</a:t>
+            </a:r>
+          </a:p>
+          <a:p>
+            <a:r>
+              <a:t>- Khiêm tốn khoa học: Trong an toàn thông tin không có 'bảo vệ tuyệt đối 100%'. Mục tiêu thực tế là Giảm thiểu rủi ro thực nghiệm (Empirical Risk Mitigation) hiệu quả, chạy nhanh và tiết kiệm chi phí trên CPU thông thường.</a:t>
+            </a:r>
+          </a:p>
+          <a:p>
+            <a:r>
+              <a:t>- Cảm ơn Thầy Ninh đã tận tình hướng dẫn và mở đầu phiên trao đổi, giải đáp câu hỏi (Q&amp;A).</a:t>
+            </a:r>
+          </a:p>
+          <a:p>
+            <a:r>
+              <a:t>[TÁC PHONG]: Cả nhóm cúi đầu nhẹ, mỉm cười cầu thị, chuẩn bị sổ tay ghi nhận góp ý của GVHD.</a:t>
+            </a:r>
+          </a:p>
+        </p:txBody>
+      </p:sp>
+      <p:sp>
+        <p:nvSpPr>
+          <p:cNvPr id="4" name="Slide Number Placeholder 3"/>
+          <p:cNvSpPr>
+            <a:spLocks noGrp="1"/>
+          </p:cNvSpPr>
+          <p:nvPr>
+            <p:ph type="sldNum" idx="5" sz="quarter"/>
+          </p:nvPr>
+        </p:nvSpPr>
+        <p:spPr/>
+      </p:sp>
+    </p:spTree>
+  </p:cSld>
+  <p:clrMapOvr>
+    <a:masterClrMapping/>
+  </p:clrMapOvr>
+</p:notes>
 </file>
 
 <file path=ppt/slideLayouts/slideLayout1.xml><?xml version="1.0" encoding="utf-8"?>
@@ -48672,4 +49867,324 @@
   <a:objectDefaults/>
   <a:extraClrSchemeLst/>
 </a:theme>
+</file>
+
+<file path=ppt/theme/theme2.xml><?xml version="1.0" encoding="utf-8"?>
+<a:theme xmlns:a="http://schemas.openxmlformats.org/drawingml/2006/main" name="Office Theme">
+  <a:themeElements>
+    <a:clrScheme name="Office">
+      <a:dk1>
+        <a:sysClr val="windowText" lastClr="000000"/>
+      </a:dk1>
+      <a:lt1>
+        <a:sysClr val="window" lastClr="FFFFFF"/>
+      </a:lt1>
+      <a:dk2>
+        <a:srgbClr val="1F497D"/>
+      </a:dk2>
+      <a:lt2>
+        <a:srgbClr val="EEECE1"/>
+      </a:lt2>
+      <a:accent1>
+        <a:srgbClr val="4F81BD"/>
+      </a:accent1>
+      <a:accent2>
+        <a:srgbClr val="C0504D"/>
+      </a:accent2>
+      <a:accent3>
+        <a:srgbClr val="9BBB59"/>
+      </a:accent3>
+      <a:accent4>
+        <a:srgbClr val="8064A2"/>
+      </a:accent4>
+      <a:accent5>
+        <a:srgbClr val="4BACC6"/>
+      </a:accent5>
+      <a:accent6>
+        <a:srgbClr val="F79646"/>
+      </a:accent6>
+      <a:hlink>
+        <a:srgbClr val="0000FF"/>
+      </a:hlink>
+      <a:folHlink>
+        <a:srgbClr val="800080"/>
+      </a:folHlink>
+    </a:clrScheme>
+    <a:fontScheme name="Office">
+      <a:majorFont>
+        <a:latin typeface="Calibri"/>
+        <a:ea typeface=""/>
+        <a:cs typeface=""/>
+        <a:font script="Jpan" typeface="ＭＳ Ｐゴシック"/>
+        <a:font script="Hang" typeface="맑은 고딕"/>
+        <a:font script="Hans" typeface="宋体"/>
+        <a:font script="Hant" typeface="新細明體"/>
+        <a:font script="Arab" typeface="Times New Roman"/>
+        <a:font script="Hebr" typeface="Times New Roman"/>
+        <a:font script="Thai" typeface="Angsana New"/>
+        <a:font script="Ethi" typeface="Nyala"/>
+        <a:font script="Beng" typeface="Vrinda"/>
+        <a:font script="Gujr" typeface="Shruti"/>
+        <a:font script="Khmr" typeface="MoolBoran"/>
+        <a:font script="Knda" typeface="Tunga"/>
+        <a:font script="Guru" typeface="Raavi"/>
+        <a:font script="Cans" typeface="Euphemia"/>
+        <a:font script="Cher" typeface="Plantagenet Cherokee"/>
+        <a:font script="Yiii" typeface="Microsoft Yi Baiti"/>
+        <a:font script="Tibt" typeface="Microsoft Himalaya"/>
+        <a:font script="Thaa" typeface="MV Boli"/>
+        <a:font script="Deva" typeface="Mangal"/>
+        <a:font script="Telu" typeface="Gautami"/>
+        <a:font script="Taml" typeface="Latha"/>
+        <a:font script="Syrc" typeface="Estrangelo Edessa"/>
+        <a:font script="Orya" typeface="Kalinga"/>
+        <a:font script="Mlym" typeface="Kartika"/>
+        <a:font script="Laoo" typeface="DokChampa"/>
+        <a:font script="Sinh" typeface="Iskoola Pota"/>
+        <a:font script="Mong" typeface="Mongolian Baiti"/>
+        <a:font script="Viet" typeface="Times New Roman"/>
+        <a:font script="Uigh" typeface="Microsoft Uighur"/>
+        <a:font script="Geor" typeface="Sylfaen"/>
+      </a:majorFont>
+      <a:minorFont>
+        <a:latin typeface="Calibri"/>
+        <a:ea typeface=""/>
+        <a:cs typeface=""/>
+        <a:font script="Jpan" typeface="ＭＳ Ｐゴシック"/>
+        <a:font script="Hang" typeface="맑은 고딕"/>
+        <a:font script="Hans" typeface="宋体"/>
+        <a:font script="Hant" typeface="新細明體"/>
+        <a:font script="Arab" typeface="Arial"/>
+        <a:font script="Hebr" typeface="Arial"/>
+        <a:font script="Thai" typeface="Cordia New"/>
+        <a:font script="Ethi" typeface="Nyala"/>
+        <a:font script="Beng" typeface="Vrinda"/>
+        <a:font script="Gujr" typeface="Shruti"/>
+        <a:font script="Khmr" typeface="DaunPenh"/>
+        <a:font script="Knda" typeface="Tunga"/>
+        <a:font script="Guru" typeface="Raavi"/>
+        <a:font script="Cans" typeface="Euphemia"/>
+        <a:font script="Cher" typeface="Plantagenet Cherokee"/>
+        <a:font script="Yiii" typeface="Microsoft Yi Baiti"/>
+        <a:font script="Tibt" typeface="Microsoft Himalaya"/>
+        <a:font script="Thaa" typeface="MV Boli"/>
+        <a:font script="Deva" typeface="Mangal"/>
+        <a:font script="Telu" typeface="Gautami"/>
+        <a:font script="Taml" typeface="Latha"/>
+        <a:font script="Syrc" typeface="Estrangelo Edessa"/>
+        <a:font script="Orya" typeface="Kalinga"/>
+        <a:font script="Mlym" typeface="Kartika"/>
+        <a:font script="Laoo" typeface="DokChampa"/>
+        <a:font script="Sinh" typeface="Iskoola Pota"/>
+        <a:font script="Mong" typeface="Mongolian Baiti"/>
+        <a:font script="Viet" typeface="Arial"/>
+        <a:font script="Uigh" typeface="Microsoft Uighur"/>
+        <a:font script="Geor" typeface="Sylfaen"/>
+      </a:minorFont>
+    </a:fontScheme>
+    <a:fmtScheme name="Office">
+      <a:fillStyleLst>
+        <a:solidFill>
+          <a:schemeClr val="phClr"/>
+        </a:solidFill>
+        <a:gradFill rotWithShape="1">
+          <a:gsLst>
+            <a:gs pos="0">
+              <a:schemeClr val="phClr">
+                <a:tint val="50000"/>
+                <a:satMod val="300000"/>
+              </a:schemeClr>
+            </a:gs>
+            <a:gs pos="35000">
+              <a:schemeClr val="phClr">
+                <a:tint val="37000"/>
+                <a:satMod val="300000"/>
+              </a:schemeClr>
+            </a:gs>
+            <a:gs pos="100000">
+              <a:schemeClr val="phClr">
+                <a:tint val="15000"/>
+                <a:satMod val="350000"/>
+              </a:schemeClr>
+            </a:gs>
+          </a:gsLst>
+          <a:lin ang="16200000" scaled="1"/>
+        </a:gradFill>
+        <a:gradFill rotWithShape="1">
+          <a:gsLst>
+            <a:gs pos="0">
+              <a:schemeClr val="phClr">
+                <a:tint val="100000"/>
+                <a:shade val="100000"/>
+                <a:satMod val="130000"/>
+              </a:schemeClr>
+            </a:gs>
+            <a:gs pos="100000">
+              <a:schemeClr val="phClr">
+                <a:tint val="50000"/>
+                <a:shade val="100000"/>
+                <a:satMod val="350000"/>
+              </a:schemeClr>
+            </a:gs>
+          </a:gsLst>
+          <a:lin ang="16200000" scaled="0"/>
+        </a:gradFill>
+      </a:fillStyleLst>
+      <a:lnStyleLst>
+        <a:ln w="9525" cap="flat" cmpd="sng" algn="ctr">
+          <a:solidFill>
+            <a:schemeClr val="phClr">
+              <a:shade val="95000"/>
+              <a:satMod val="105000"/>
+            </a:schemeClr>
+          </a:solidFill>
+          <a:prstDash val="solid"/>
+        </a:ln>
+        <a:ln w="25400" cap="flat" cmpd="sng" algn="ctr">
+          <a:solidFill>
+            <a:schemeClr val="phClr"/>
+          </a:solidFill>
+          <a:prstDash val="solid"/>
+        </a:ln>
+        <a:ln w="38100" cap="flat" cmpd="sng" algn="ctr">
+          <a:solidFill>
+            <a:schemeClr val="phClr"/>
+          </a:solidFill>
+          <a:prstDash val="solid"/>
+        </a:ln>
+      </a:lnStyleLst>
+      <a:effectStyleLst>
+        <a:effectStyle>
+          <a:effectLst>
+            <a:outerShdw blurRad="40000" dist="20000" dir="5400000" rotWithShape="0">
+              <a:srgbClr val="000000">
+                <a:alpha val="38000"/>
+              </a:srgbClr>
+            </a:outerShdw>
+          </a:effectLst>
+        </a:effectStyle>
+        <a:effectStyle>
+          <a:effectLst>
+            <a:outerShdw blurRad="40000" dist="23000" dir="5400000" rotWithShape="0">
+              <a:srgbClr val="000000">
+                <a:alpha val="35000"/>
+              </a:srgbClr>
+            </a:outerShdw>
+          </a:effectLst>
+        </a:effectStyle>
+        <a:effectStyle>
+          <a:effectLst>
+            <a:outerShdw blurRad="40000" dist="23000" dir="5400000" rotWithShape="0">
+              <a:srgbClr val="000000">
+                <a:alpha val="35000"/>
+              </a:srgbClr>
+            </a:outerShdw>
+          </a:effectLst>
+          <a:scene3d>
+            <a:camera prst="orthographicFront">
+              <a:rot lat="0" lon="0" rev="0"/>
+            </a:camera>
+            <a:lightRig rig="threePt" dir="t">
+              <a:rot lat="0" lon="0" rev="1200000"/>
+            </a:lightRig>
+          </a:scene3d>
+          <a:sp3d>
+            <a:bevelT w="63500" h="25400"/>
+          </a:sp3d>
+        </a:effectStyle>
+      </a:effectStyleLst>
+      <a:bgFillStyleLst>
+        <a:solidFill>
+          <a:schemeClr val="phClr"/>
+        </a:solidFill>
+        <a:gradFill rotWithShape="1">
+          <a:gsLst>
+            <a:gs pos="0">
+              <a:schemeClr val="phClr">
+                <a:tint val="40000"/>
+                <a:satMod val="350000"/>
+              </a:schemeClr>
+            </a:gs>
+            <a:gs pos="40000">
+              <a:schemeClr val="phClr">
+                <a:tint val="45000"/>
+                <a:shade val="99000"/>
+                <a:satMod val="350000"/>
+              </a:schemeClr>
+            </a:gs>
+            <a:gs pos="100000">
+              <a:schemeClr val="phClr">
+                <a:shade val="20000"/>
+                <a:satMod val="255000"/>
+              </a:schemeClr>
+            </a:gs>
+          </a:gsLst>
+          <a:path path="circle">
+            <a:fillToRect l="50000" t="-80000" r="50000" b="180000"/>
+          </a:path>
+        </a:gradFill>
+        <a:gradFill rotWithShape="1">
+          <a:gsLst>
+            <a:gs pos="0">
+              <a:schemeClr val="phClr">
+                <a:tint val="80000"/>
+                <a:satMod val="300000"/>
+              </a:schemeClr>
+            </a:gs>
+            <a:gs pos="100000">
+              <a:schemeClr val="phClr">
+                <a:shade val="30000"/>
+                <a:satMod val="200000"/>
+              </a:schemeClr>
+            </a:gs>
+          </a:gsLst>
+          <a:path path="circle">
+            <a:fillToRect l="50000" t="50000" r="50000" b="50000"/>
+          </a:path>
+        </a:gradFill>
+      </a:bgFillStyleLst>
+    </a:fmtScheme>
+  </a:themeElements>
+  <a:objectDefaults>
+    <a:spDef>
+      <a:spPr/>
+      <a:bodyPr/>
+      <a:lstStyle/>
+      <a:style>
+        <a:lnRef idx="1">
+          <a:schemeClr val="accent1"/>
+        </a:lnRef>
+        <a:fillRef idx="3">
+          <a:schemeClr val="accent1"/>
+        </a:fillRef>
+        <a:effectRef idx="2">
+          <a:schemeClr val="accent1"/>
+        </a:effectRef>
+        <a:fontRef idx="minor">
+          <a:schemeClr val="lt1"/>
+        </a:fontRef>
+      </a:style>
+    </a:spDef>
+    <a:lnDef>
+      <a:spPr/>
+      <a:bodyPr/>
+      <a:lstStyle/>
+      <a:style>
+        <a:lnRef idx="2">
+          <a:schemeClr val="accent1"/>
+        </a:lnRef>
+        <a:fillRef idx="0">
+          <a:schemeClr val="accent1"/>
+        </a:fillRef>
+        <a:effectRef idx="1">
+          <a:schemeClr val="accent1"/>
+        </a:effectRef>
+        <a:fontRef idx="minor">
+          <a:schemeClr val="tx1"/>
+        </a:fontRef>
+      </a:style>
+    </a:lnDef>
+  </a:objectDefaults>
+  <a:extraClrSchemeLst/>
+</a:theme>
 </file>
</xml_diff>